<commit_message>
Integrate three-layer tempo analogy + PoC A-H results from companion sessions
Major additions:
- Three-layer tempo analogy (Population -> GDP -> Healthcare) from PR#39
- Specific healthcare_tempo_poc Candidate A-H results from PR#37
  M2 beats M1 in 95% of 39 countries, mu_H1 = +0.15 yr/yr
- Candidate D-H discussion (spending composition as forgotten parameter)
- US-Japan comparison through tempo lens
- Figure 5: Three-layer analogy table (EN + JA)
- 4 new references (#17-20): Bongaarts-Feeney, Goldstein-Lutz-Scherbov,
  Onishi GDP paper, Onishi healthcare PoC
- Updated README with companion paper table

Co-Authored-By: Tatsuki Onishi <bougtoir@gmail.com>
</commit_message>
<xml_diff>
--- a/healthcare_economic_effect/output/pptx/Healthcare_Economic_Effect_Figures_EN.pptx
+++ b/healthcare_economic_effect/output/pptx/Healthcare_Economic_Effect_Figures_EN.pptx
@@ -9,6 +9,7 @@
     <p:sldId id="257" r:id="rId8"/>
     <p:sldId id="258" r:id="rId9"/>
     <p:sldId id="259" r:id="rId10"/>
+    <p:sldId id="260" r:id="rId11"/>
   </p:sldIdLst>
   <p:sldSz cx="12191695" cy="6858000" type="screen4x3"/>
   <p:notesSz cx="6858000" cy="9144000"/>
@@ -3485,6 +3486,110 @@
             </a:pPr>
             <a:r>
               <a:t>Healthcare spending generates returns through two channels: demand-side (I-O multiplier) and supply-side (health-capital tempo effect).</a:t>
+            </a:r>
+          </a:p>
+        </p:txBody>
+      </p:sp>
+    </p:spTree>
+  </p:cSld>
+  <p:clrMapOvr>
+    <a:masterClrMapping/>
+  </p:clrMapOvr>
+</p:sld>
+</file>
+
+<file path=ppt/slides/slide5.xml><?xml version="1.0" encoding="utf-8"?>
+<p:sld xmlns:a="http://schemas.openxmlformats.org/drawingml/2006/main" xmlns:p="http://schemas.openxmlformats.org/presentationml/2006/main" xmlns:r="http://schemas.openxmlformats.org/officeDocument/2006/relationships">
+  <p:cSld>
+    <p:spTree>
+      <p:nvGrpSpPr>
+        <p:cNvPr id="1" name=""/>
+        <p:cNvGrpSpPr/>
+        <p:nvPr/>
+      </p:nvGrpSpPr>
+      <p:grpSpPr/>
+      <p:sp>
+        <p:nvSpPr>
+          <p:cNvPr id="2" name="TextBox 1"/>
+          <p:cNvSpPr txBox="1"/>
+          <p:nvPr/>
+        </p:nvSpPr>
+        <p:spPr>
+          <a:xfrm>
+            <a:off x="457200" y="182880"/>
+            <a:ext cx="11274552" cy="548640"/>
+          </a:xfrm>
+          <a:prstGeom prst="rect">
+            <a:avLst/>
+          </a:prstGeom>
+          <a:noFill/>
+        </p:spPr>
+        <p:txBody>
+          <a:bodyPr wrap="none">
+            <a:spAutoFit/>
+          </a:bodyPr>
+          <a:lstStyle/>
+          <a:p>
+            <a:pPr algn="ctr">
+              <a:defRPr sz="1800" b="1"/>
+            </a:pPr>
+            <a:r>
+              <a:t>Figure 5. Three-Layer Tempo Analogy: Population -&gt; GDP -&gt; Healthcare</a:t>
+            </a:r>
+          </a:p>
+        </p:txBody>
+      </p:sp>
+      <p:pic>
+        <p:nvPicPr>
+          <p:cNvPr id="3" name="Picture 2" descr="fig5_three_layer_analogy.png"/>
+          <p:cNvPicPr>
+            <a:picLocks noChangeAspect="1"/>
+          </p:cNvPicPr>
+          <p:nvPr/>
+        </p:nvPicPr>
+        <p:blipFill>
+          <a:blip r:embed="rId2"/>
+          <a:stretch>
+            <a:fillRect/>
+          </a:stretch>
+        </p:blipFill>
+        <p:spPr>
+          <a:xfrm>
+            <a:off x="1371600" y="914400"/>
+            <a:ext cx="9445752" cy="4572000"/>
+          </a:xfrm>
+          <a:prstGeom prst="rect">
+            <a:avLst/>
+          </a:prstGeom>
+        </p:spPr>
+      </p:pic>
+      <p:sp>
+        <p:nvSpPr>
+          <p:cNvPr id="4" name="TextBox 3"/>
+          <p:cNvSpPr txBox="1"/>
+          <p:nvPr/>
+        </p:nvSpPr>
+        <p:spPr>
+          <a:xfrm>
+            <a:off x="457200" y="5760720"/>
+            <a:ext cx="11274552" cy="731520"/>
+          </a:xfrm>
+          <a:prstGeom prst="rect">
+            <a:avLst/>
+          </a:prstGeom>
+          <a:noFill/>
+        </p:spPr>
+        <p:txBody>
+          <a:bodyPr wrap="square">
+            <a:spAutoFit/>
+          </a:bodyPr>
+          <a:lstStyle/>
+          <a:p>
+            <a:pPr algn="ctr">
+              <a:defRPr sz="1000" i="1"/>
+            </a:pPr>
+            <a:r>
+              <a:t>The Bongaarts-Feeney tempo framework ported across three domains. Healthcare shows the largest tempo drift (+0.15 yr/yr vs GDP +0.04).</a:t>
             </a:r>
           </a:p>
         </p:txBody>

</xml_diff>

<commit_message>
Add medical equipment stock & import leakage analysis: equipment density comparison, import leakage model, Japan counterfactuals (3 scenarios), JA/EN figures with CJK font support
New section 4.2 in both manuscripts:
- Japan CT+MRI density 170.9/million (4x OECD median)
- Import leakage ~5% CHE reduces effective multiplier 2.78->2.64
- Counterfactual A (avg density): fiscal return drops to 0.98
- Counterfactual B (domestic mfg): fiscal return rises to 1.09
- Counterfactual C (both): 1.03 -- effects roughly offset
- Cross-country comparison of 13 OECD nations

New figures 6-8 (EN + JA versions), new data files, updated pptx.

Co-Authored-By: Tatsuki Onishi <bougtoir@gmail.com>
</commit_message>
<xml_diff>
--- a/healthcare_economic_effect/output/pptx/Healthcare_Economic_Effect_Figures_EN.pptx
+++ b/healthcare_economic_effect/output/pptx/Healthcare_Economic_Effect_Figures_EN.pptx
@@ -10,6 +10,9 @@
     <p:sldId id="258" r:id="rId9"/>
     <p:sldId id="259" r:id="rId10"/>
     <p:sldId id="260" r:id="rId11"/>
+    <p:sldId id="261" r:id="rId12"/>
+    <p:sldId id="262" r:id="rId13"/>
+    <p:sldId id="263" r:id="rId14"/>
   </p:sldIdLst>
   <p:sldSz cx="12191695" cy="6858000" type="screen4x3"/>
   <p:notesSz cx="6858000" cy="9144000"/>
@@ -3589,7 +3592,319 @@
               <a:defRPr sz="1000" i="1"/>
             </a:pPr>
             <a:r>
-              <a:t>X-axis: CHE as % of GDP. Y-axis: Life expectancy at birth (years). Linear fit excludes US (outlier shown in red).</a:t>
+              <a:t>X-axis: CHE as % of GDP. Y-axis: Life expectancy at birth (years). Linear fit excludes US (outlier shown in red). F-test results in figure.</a:t>
+            </a:r>
+          </a:p>
+        </p:txBody>
+      </p:sp>
+    </p:spTree>
+  </p:cSld>
+  <p:clrMapOvr>
+    <a:masterClrMapping/>
+  </p:clrMapOvr>
+</p:sld>
+</file>
+
+<file path=ppt/slides/slide6.xml><?xml version="1.0" encoding="utf-8"?>
+<p:sld xmlns:a="http://schemas.openxmlformats.org/drawingml/2006/main" xmlns:p="http://schemas.openxmlformats.org/presentationml/2006/main" xmlns:r="http://schemas.openxmlformats.org/officeDocument/2006/relationships">
+  <p:cSld>
+    <p:spTree>
+      <p:nvGrpSpPr>
+        <p:cNvPr id="1" name=""/>
+        <p:cNvGrpSpPr/>
+        <p:nvPr/>
+      </p:nvGrpSpPr>
+      <p:grpSpPr/>
+      <p:sp>
+        <p:nvSpPr>
+          <p:cNvPr id="2" name="TextBox 1"/>
+          <p:cNvSpPr txBox="1"/>
+          <p:nvPr/>
+        </p:nvSpPr>
+        <p:spPr>
+          <a:xfrm>
+            <a:off x="457200" y="182880"/>
+            <a:ext cx="11274552" cy="548640"/>
+          </a:xfrm>
+          <a:prstGeom prst="rect">
+            <a:avLst/>
+          </a:prstGeom>
+          <a:noFill/>
+        </p:spPr>
+        <p:txBody>
+          <a:bodyPr wrap="none">
+            <a:spAutoFit/>
+          </a:bodyPr>
+          <a:lstStyle/>
+          <a:p>
+            <a:pPr algn="ctr">
+              <a:defRPr sz="1800" b="1"/>
+            </a:pPr>
+            <a:r>
+              <a:t>Figure 6. Diagnostic Imaging Equipment Density (CT+MRI, OECD 2021)</a:t>
+            </a:r>
+          </a:p>
+        </p:txBody>
+      </p:sp>
+      <p:pic>
+        <p:nvPicPr>
+          <p:cNvPr id="3" name="Picture 2" descr="fig6_equipment_density.png"/>
+          <p:cNvPicPr>
+            <a:picLocks noChangeAspect="1"/>
+          </p:cNvPicPr>
+          <p:nvPr/>
+        </p:nvPicPr>
+        <p:blipFill>
+          <a:blip r:embed="rId2"/>
+          <a:stretch>
+            <a:fillRect/>
+          </a:stretch>
+        </p:blipFill>
+        <p:spPr>
+          <a:xfrm>
+            <a:off x="1371600" y="914400"/>
+            <a:ext cx="9445752" cy="4572000"/>
+          </a:xfrm>
+          <a:prstGeom prst="rect">
+            <a:avLst/>
+          </a:prstGeom>
+        </p:spPr>
+      </p:pic>
+      <p:sp>
+        <p:nvSpPr>
+          <p:cNvPr id="4" name="TextBox 3"/>
+          <p:cNvSpPr txBox="1"/>
+          <p:nvPr/>
+        </p:nvSpPr>
+        <p:spPr>
+          <a:xfrm>
+            <a:off x="457200" y="5760720"/>
+            <a:ext cx="11274552" cy="731520"/>
+          </a:xfrm>
+          <a:prstGeom prst="rect">
+            <a:avLst/>
+          </a:prstGeom>
+          <a:noFill/>
+        </p:spPr>
+        <p:txBody>
+          <a:bodyPr wrap="square">
+            <a:spAutoFit/>
+          </a:bodyPr>
+          <a:lstStyle/>
+          <a:p>
+            <a:pPr algn="ctr">
+              <a:defRPr sz="1000" i="1"/>
+            </a:pPr>
+            <a:r>
+              <a:t>Combined CT and MRI scanners per million population. Japan (red) at 170.9 is approximately 4x the OECD median.</a:t>
+            </a:r>
+          </a:p>
+        </p:txBody>
+      </p:sp>
+    </p:spTree>
+  </p:cSld>
+  <p:clrMapOvr>
+    <a:masterClrMapping/>
+  </p:clrMapOvr>
+</p:sld>
+</file>
+
+<file path=ppt/slides/slide7.xml><?xml version="1.0" encoding="utf-8"?>
+<p:sld xmlns:a="http://schemas.openxmlformats.org/drawingml/2006/main" xmlns:p="http://schemas.openxmlformats.org/presentationml/2006/main" xmlns:r="http://schemas.openxmlformats.org/officeDocument/2006/relationships">
+  <p:cSld>
+    <p:spTree>
+      <p:nvGrpSpPr>
+        <p:cNvPr id="1" name=""/>
+        <p:cNvGrpSpPr/>
+        <p:nvPr/>
+      </p:nvGrpSpPr>
+      <p:grpSpPr/>
+      <p:sp>
+        <p:nvSpPr>
+          <p:cNvPr id="2" name="TextBox 1"/>
+          <p:cNvSpPr txBox="1"/>
+          <p:nvPr/>
+        </p:nvSpPr>
+        <p:spPr>
+          <a:xfrm>
+            <a:off x="457200" y="182880"/>
+            <a:ext cx="11274552" cy="548640"/>
+          </a:xfrm>
+          <a:prstGeom prst="rect">
+            <a:avLst/>
+          </a:prstGeom>
+          <a:noFill/>
+        </p:spPr>
+        <p:txBody>
+          <a:bodyPr wrap="none">
+            <a:spAutoFit/>
+          </a:bodyPr>
+          <a:lstStyle/>
+          <a:p>
+            <a:pPr algn="ctr">
+              <a:defRPr sz="1800" b="1"/>
+            </a:pPr>
+            <a:r>
+              <a:t>Figure 7. Medical Import Leakage vs Effective I-O Multiplier</a:t>
+            </a:r>
+          </a:p>
+        </p:txBody>
+      </p:sp>
+      <p:pic>
+        <p:nvPicPr>
+          <p:cNvPr id="3" name="Picture 2" descr="fig7_import_leakage_multiplier.png"/>
+          <p:cNvPicPr>
+            <a:picLocks noChangeAspect="1"/>
+          </p:cNvPicPr>
+          <p:nvPr/>
+        </p:nvPicPr>
+        <p:blipFill>
+          <a:blip r:embed="rId2"/>
+          <a:stretch>
+            <a:fillRect/>
+          </a:stretch>
+        </p:blipFill>
+        <p:spPr>
+          <a:xfrm>
+            <a:off x="1371600" y="914400"/>
+            <a:ext cx="9445752" cy="4572000"/>
+          </a:xfrm>
+          <a:prstGeom prst="rect">
+            <a:avLst/>
+          </a:prstGeom>
+        </p:spPr>
+      </p:pic>
+      <p:sp>
+        <p:nvSpPr>
+          <p:cNvPr id="4" name="TextBox 3"/>
+          <p:cNvSpPr txBox="1"/>
+          <p:nvPr/>
+        </p:nvSpPr>
+        <p:spPr>
+          <a:xfrm>
+            <a:off x="457200" y="5760720"/>
+            <a:ext cx="11274552" cy="731520"/>
+          </a:xfrm>
+          <a:prstGeom prst="rect">
+            <a:avLst/>
+          </a:prstGeom>
+          <a:noFill/>
+        </p:spPr>
+        <p:txBody>
+          <a:bodyPr wrap="square">
+            <a:spAutoFit/>
+          </a:bodyPr>
+          <a:lstStyle/>
+          <a:p>
+            <a:pPr algn="ctr">
+              <a:defRPr sz="1000" i="1"/>
+            </a:pPr>
+            <a:r>
+              <a:t>Import leakage reduces the effective I-O multiplier. Gray x = nominal multiplier. Red arrow = Japan's leakage adjustment.</a:t>
+            </a:r>
+          </a:p>
+        </p:txBody>
+      </p:sp>
+    </p:spTree>
+  </p:cSld>
+  <p:clrMapOvr>
+    <a:masterClrMapping/>
+  </p:clrMapOvr>
+</p:sld>
+</file>
+
+<file path=ppt/slides/slide8.xml><?xml version="1.0" encoding="utf-8"?>
+<p:sld xmlns:a="http://schemas.openxmlformats.org/drawingml/2006/main" xmlns:p="http://schemas.openxmlformats.org/presentationml/2006/main" xmlns:r="http://schemas.openxmlformats.org/officeDocument/2006/relationships">
+  <p:cSld>
+    <p:spTree>
+      <p:nvGrpSpPr>
+        <p:cNvPr id="1" name=""/>
+        <p:cNvGrpSpPr/>
+        <p:nvPr/>
+      </p:nvGrpSpPr>
+      <p:grpSpPr/>
+      <p:sp>
+        <p:nvSpPr>
+          <p:cNvPr id="2" name="TextBox 1"/>
+          <p:cNvSpPr txBox="1"/>
+          <p:nvPr/>
+        </p:nvSpPr>
+        <p:spPr>
+          <a:xfrm>
+            <a:off x="457200" y="182880"/>
+            <a:ext cx="11274552" cy="548640"/>
+          </a:xfrm>
+          <a:prstGeom prst="rect">
+            <a:avLst/>
+          </a:prstGeom>
+          <a:noFill/>
+        </p:spPr>
+        <p:txBody>
+          <a:bodyPr wrap="none">
+            <a:spAutoFit/>
+          </a:bodyPr>
+          <a:lstStyle/>
+          <a:p>
+            <a:pPr algn="ctr">
+              <a:defRPr sz="1800" b="1"/>
+            </a:pPr>
+            <a:r>
+              <a:t>Figure 8. Japan Counterfactual Sustainability Scenarios</a:t>
+            </a:r>
+          </a:p>
+        </p:txBody>
+      </p:sp>
+      <p:pic>
+        <p:nvPicPr>
+          <p:cNvPr id="3" name="Picture 2" descr="fig8_counterfactual_japan.png"/>
+          <p:cNvPicPr>
+            <a:picLocks noChangeAspect="1"/>
+          </p:cNvPicPr>
+          <p:nvPr/>
+        </p:nvPicPr>
+        <p:blipFill>
+          <a:blip r:embed="rId2"/>
+          <a:stretch>
+            <a:fillRect/>
+          </a:stretch>
+        </p:blipFill>
+        <p:spPr>
+          <a:xfrm>
+            <a:off x="1371600" y="914400"/>
+            <a:ext cx="9445752" cy="4572000"/>
+          </a:xfrm>
+          <a:prstGeom prst="rect">
+            <a:avLst/>
+          </a:prstGeom>
+        </p:spPr>
+      </p:pic>
+      <p:sp>
+        <p:nvSpPr>
+          <p:cNvPr id="4" name="TextBox 3"/>
+          <p:cNvSpPr txBox="1"/>
+          <p:nvPr/>
+        </p:nvSpPr>
+        <p:spPr>
+          <a:xfrm>
+            <a:off x="457200" y="5760720"/>
+            <a:ext cx="11274552" cy="731520"/>
+          </a:xfrm>
+          <a:prstGeom prst="rect">
+            <a:avLst/>
+          </a:prstGeom>
+          <a:noFill/>
+        </p:spPr>
+        <p:txBody>
+          <a:bodyPr wrap="square">
+            <a:spAutoFit/>
+          </a:bodyPr>
+          <a:lstStyle/>
+          <a:p>
+            <a:pPr algn="ctr">
+              <a:defRPr sz="1000" i="1"/>
+            </a:pPr>
+            <a:r>
+              <a:t>Baseline (1.04), A: OECD-avg equipment (0.98), B: Domestic manufacturing (1.09), C: Both (1.03).</a:t>
             </a:r>
           </a:p>
         </p:txBody>

</xml_diff>